<commit_message>
L6: if/else (dispensa, slide, passo 8 sulle regioni poco affidabili)
Co-Authored-By: Claude Opus 5.5 <noreply@anthropic.com>
Claude-Session: https://claude.ai/code/session_014CzWDFXvYNxqLeD99LSN3G
</commit_message>
<xml_diff>
--- a/lezioni/L06_funzioni_cicli/slide.pptx
+++ b/lezioni/L06_funzioni_cicli/slide.pptx
@@ -13,9 +13,10 @@
     <p:sldId id="261" r:id="rId7"/>
     <p:sldId id="262" r:id="rId8"/>
     <p:sldId id="263" r:id="rId9"/>
+    <p:sldId id="264" r:id="rId10"/>
   </p:sldIdLst>
   <p:notesMasterIdLst>
-    <p:notesMasterId r:id="rId10"/>
+    <p:notesMasterId r:id="rId11"/>
   </p:notesMasterIdLst>
   <p:sldSz cx="12192000" cy="6858000"/>
   <p:notesSz cx="6858000" cy="12192000"/>
@@ -114,28 +115,29 @@
   <p:extLst>
     <p:ext uri="{521415D9-36F7-43E2-AB2F-B90AF26B5E84}">
       <p14:sectionLst xmlns:p14="http://schemas.microsoft.com/office/powerpoint/2010/main">
-        <p14:section name="Apertura" id="{ee390536-1ec7-3225-bd49-5bc6d32422bd}">
+        <p14:section name="Apertura" id="{a2f4acc8-94be-da91-f284-fd7c678a05c6}">
           <p14:sldIdLst>
             <p14:sldId id="256"/>
             <p14:sldId id="257"/>
           </p14:sldIdLst>
         </p14:section>
-        <p14:section name="Spiegazione" id="{c1f7afa8-0f0d-b0d4-9b33-3874c1a44e14}">
+        <p14:section name="Spiegazione" id="{8f87d297-5491-3bc7-4f4a-0d8aefbdd3e8}">
           <p14:sldIdLst>
             <p14:sldId id="258"/>
             <p14:sldId id="259"/>
             <p14:sldId id="260"/>
             <p14:sldId id="261"/>
-          </p14:sldIdLst>
-        </p14:section>
-        <p14:section name="Task" id="{c588c6f8-bdae-7030-9cfb-777e07ac235b}">
-          <p14:sldIdLst>
             <p14:sldId id="262"/>
           </p14:sldIdLst>
         </p14:section>
-        <p14:section name="Chiusura" id="{6d1c3ab7-fc5b-06ff-0117-dbb69f5f1a90}">
+        <p14:section name="Task" id="{4975393b-c37c-8312-6697-d330c3d27f69}">
           <p14:sldIdLst>
             <p14:sldId id="263"/>
+          </p14:sldIdLst>
+        </p14:section>
+        <p14:section name="Chiusura" id="{5fb9dcea-e766-60c7-7973-5be24d610257}">
+          <p14:sldIdLst>
+            <p14:sldId id="264"/>
           </p14:sldIdLst>
         </p14:section>
       </p14:sectionLst>
@@ -894,7 +896,7 @@
           <a:p>
             <a:r>
               <a:rPr lang="en-US" dirty="0"/>
-              <a:t>Mostrare il pannello dei file di Colab dopo il git clone. Path è il modo moderno di gestire i percorsi in Python.</a:t>
+              <a:t>DEMO: cambiare imprese in 40 e rieseguire. Poi mostrare l'errore di if df["addetti"] &lt; 10: «The truth value of a Series is ambiguous»: if decide su un valore solo.</a:t>
             </a:r>
             <a:endParaRPr lang="en-US" dirty="0"/>
           </a:p>
@@ -982,7 +984,7 @@
           <a:p>
             <a:r>
               <a:rPr lang="en-US" dirty="0"/>
-              <a:t>Non anticipare quale file darà problemi.</a:t>
+              <a:t>Mostrare il pannello dei file di Colab dopo il git clone. Path è il modo moderno di gestire i percorsi in Python.</a:t>
             </a:r>
             <a:endParaRPr lang="en-US" dirty="0"/>
           </a:p>
@@ -1070,7 +1072,7 @@
           <a:p>
             <a:r>
               <a:rPr lang="en-US" dirty="0"/>
-              <a:t>Al passo 6 il ciclo si ferma: è voluto. Aiutare a leggere l'errore, non a risolverlo.</a:t>
+              <a:t>Non anticipare quale file darà problemi.</a:t>
             </a:r>
             <a:endParaRPr lang="en-US" dirty="0"/>
           </a:p>
@@ -1158,7 +1160,7 @@
           <a:p>
             <a:r>
               <a:rPr lang="en-US" dirty="0"/>
-              <a:t/>
+              <a:t>Al passo 6 il ciclo si ferma: è voluto. Aiutare a leggere l'errore, non a risolverlo.</a:t>
             </a:r>
             <a:endParaRPr lang="en-US" dirty="0"/>
           </a:p>
@@ -1182,6 +1184,94 @@
             <a:fld id="{F7021451-1387-4CA6-816F-3879F97B5CBC}" type="slidenum">
               <a:rPr lang="en-US"/>
               <a:t>8</a:t>
+            </a:fld>
+            <a:endParaRPr lang="en-US"/>
+          </a:p>
+        </p:txBody>
+      </p:sp>
+    </p:spTree>
+    <p:extLst>
+      <p:ext uri="{BB962C8B-B14F-4D97-AF65-F5344CB8AC3E}">
+        <p14:creationId xmlns:p14="http://schemas.microsoft.com/office/powerpoint/2010/main" val="1024086991"/>
+      </p:ext>
+    </p:extLst>
+  </p:cSld>
+  <p:clrMapOvr>
+    <a:masterClrMapping/>
+  </p:clrMapOvr>
+</p:notes>
+</file>
+
+<file path=ppt/notesSlides/notesSlide9.xml><?xml version="1.0" encoding="utf-8"?>
+<p:notes xmlns:a="http://schemas.openxmlformats.org/drawingml/2006/main" xmlns:r="http://schemas.openxmlformats.org/officeDocument/2006/relationships" xmlns:p="http://schemas.openxmlformats.org/presentationml/2006/main">
+  <p:cSld>
+    <p:spTree>
+      <p:nvGrpSpPr>
+        <p:cNvPr id="1" name=""/>
+        <p:cNvGrpSpPr/>
+        <p:nvPr/>
+      </p:nvGrpSpPr>
+      <p:grpSpPr>
+        <a:xfrm>
+          <a:off x="0" y="0"/>
+          <a:ext cx="0" cy="0"/>
+          <a:chOff x="0" y="0"/>
+          <a:chExt cx="0" cy="0"/>
+        </a:xfrm>
+      </p:grpSpPr>
+      <p:sp>
+        <p:nvSpPr>
+          <p:cNvPr id="2" name="Slide Image Placeholder 1"/>
+          <p:cNvSpPr>
+            <a:spLocks noGrp="1" noRot="1" noChangeAspect="1"/>
+          </p:cNvSpPr>
+          <p:nvPr>
+            <p:ph type="sldImg"/>
+          </p:nvPr>
+        </p:nvSpPr>
+        <p:spPr/>
+      </p:sp>
+      <p:sp>
+        <p:nvSpPr>
+          <p:cNvPr id="3" name="Notes Placeholder 2"/>
+          <p:cNvSpPr>
+            <a:spLocks noGrp="1"/>
+          </p:cNvSpPr>
+          <p:nvPr>
+            <p:ph type="body" idx="1"/>
+          </p:nvPr>
+        </p:nvSpPr>
+        <p:spPr/>
+        <p:txBody>
+          <a:bodyPr/>
+          <a:lstStyle/>
+          <a:p>
+            <a:r>
+              <a:rPr lang="en-US" dirty="0"/>
+              <a:t/>
+            </a:r>
+            <a:endParaRPr lang="en-US" dirty="0"/>
+          </a:p>
+        </p:txBody>
+      </p:sp>
+      <p:sp>
+        <p:nvSpPr>
+          <p:cNvPr id="4" name="Slide Number Placeholder 3"/>
+          <p:cNvSpPr>
+            <a:spLocks noGrp="1"/>
+          </p:cNvSpPr>
+          <p:nvPr>
+            <p:ph type="sldNum" sz="quarter" idx="10"/>
+          </p:nvPr>
+        </p:nvSpPr>
+        <p:spPr/>
+        <p:txBody>
+          <a:bodyPr/>
+          <a:lstStyle/>
+          <a:p>
+            <a:fld id="{F7021451-1387-4CA6-816F-3879F97B5CBC}" type="slidenum">
+              <a:rPr lang="en-US"/>
+              <a:t>9</a:t>
             </a:fld>
             <a:endParaRPr lang="en-US"/>
           </a:p>
@@ -2263,7 +2353,7 @@
                   <a:srgbClr val="1F2A30"/>
                 </a:solidFill>
               </a:rPr>
-              <a:t>Funzioni, cicli, cartelle di file</a:t>
+              <a:t>Funzioni, cicli, if, cartelle di file</a:t>
             </a:r>
             <a:endParaRPr lang="en-US" sz="1600" dirty="0"/>
           </a:p>
@@ -3683,7 +3773,7 @@
                   <a:srgbClr val="0F4C5C"/>
                 </a:solidFill>
               </a:rPr>
-              <a:t>Funzione + ciclo + cartella</a:t>
+              <a:t>Decidere: if</a:t>
             </a:r>
             <a:endParaRPr lang="en-US" sz="3600" dirty="0"/>
           </a:p>
@@ -3698,11 +3788,11 @@
         <p:spPr>
           <a:xfrm>
             <a:off x="548640" y="1737360"/>
-            <a:ext cx="7315200" cy="2926080"/>
+            <a:ext cx="6583680" cy="2377440"/>
           </a:xfrm>
           <a:prstGeom prst="roundRect">
             <a:avLst>
-              <a:gd name="adj" fmla="val 3750"/>
+              <a:gd name="adj" fmla="val 4615"/>
             </a:avLst>
           </a:prstGeom>
           <a:solidFill>
@@ -3756,7 +3846,7 @@
         <p:spPr>
           <a:xfrm>
             <a:off x="777240" y="2194560"/>
-            <a:ext cx="6858000" cy="2331720"/>
+            <a:ext cx="6126480" cy="1783080"/>
           </a:xfrm>
           <a:prstGeom prst="rect">
             <a:avLst/>
@@ -3772,7 +3862,7 @@
               <a:buNone/>
             </a:pPr>
             <a:r>
-              <a:rPr lang="en-US" sz="1600" dirty="0">
+              <a:rPr lang="en-US" sz="1800" dirty="0">
                 <a:solidFill>
                   <a:srgbClr val="FFFFFF"/>
                 </a:solidFill>
@@ -3780,22 +3870,16 @@
                 <a:ea typeface="Courier New" pitchFamily="34" charset="-122"/>
                 <a:cs typeface="Courier New" pitchFamily="34" charset="-120"/>
               </a:rPr>
-              <a:t>from pathlib import Path</a:t>
-            </a:r>
-            <a:endParaRPr lang="en-US" sz="1600" dirty="0"/>
-          </a:p>
-          <a:p>
-            <a:pPr indent="0" marL="0">
-              <a:buNone/>
-            </a:pPr>
-            <a:endParaRPr lang="en-US" sz="1600" dirty="0"/>
-          </a:p>
-          <a:p>
-            <a:pPr indent="0" marL="0">
-              <a:buNone/>
-            </a:pPr>
-            <a:r>
-              <a:rPr lang="en-US" sz="1600" dirty="0">
+              <a:t>imprese = 4</a:t>
+            </a:r>
+            <a:endParaRPr lang="en-US" sz="1800" dirty="0"/>
+          </a:p>
+          <a:p>
+            <a:pPr indent="0" marL="0">
+              <a:buNone/>
+            </a:pPr>
+            <a:r>
+              <a:rPr lang="en-US" sz="1800" dirty="0">
                 <a:solidFill>
                   <a:srgbClr val="FFFFFF"/>
                 </a:solidFill>
@@ -3803,16 +3887,16 @@
                 <a:ea typeface="Courier New" pitchFamily="34" charset="-122"/>
                 <a:cs typeface="Courier New" pitchFamily="34" charset="-120"/>
               </a:rPr>
-              <a:t>file = sorted(Path("dati").glob("*.xlsx"))</a:t>
-            </a:r>
-            <a:endParaRPr lang="en-US" sz="1600" dirty="0"/>
-          </a:p>
-          <a:p>
-            <a:pPr indent="0" marL="0">
-              <a:buNone/>
-            </a:pPr>
-            <a:r>
-              <a:rPr lang="en-US" sz="1600" dirty="0">
+              <a:t>if imprese &lt; 10:</a:t>
+            </a:r>
+            <a:endParaRPr lang="en-US" sz="1800" dirty="0"/>
+          </a:p>
+          <a:p>
+            <a:pPr indent="0" marL="0">
+              <a:buNone/>
+            </a:pPr>
+            <a:r>
+              <a:rPr lang="en-US" sz="1800" dirty="0">
                 <a:solidFill>
                   <a:srgbClr val="FFFFFF"/>
                 </a:solidFill>
@@ -3820,16 +3904,16 @@
                 <a:ea typeface="Courier New" pitchFamily="34" charset="-122"/>
                 <a:cs typeface="Courier New" pitchFamily="34" charset="-120"/>
               </a:rPr>
-              <a:t>risultati = []</a:t>
-            </a:r>
-            <a:endParaRPr lang="en-US" sz="1600" dirty="0"/>
-          </a:p>
-          <a:p>
-            <a:pPr indent="0" marL="0">
-              <a:buNone/>
-            </a:pPr>
-            <a:r>
-              <a:rPr lang="en-US" sz="1600" dirty="0">
+              <a:t>    nota = "poco affidabile"</a:t>
+            </a:r>
+            <a:endParaRPr lang="en-US" sz="1800" dirty="0"/>
+          </a:p>
+          <a:p>
+            <a:pPr indent="0" marL="0">
+              <a:buNone/>
+            </a:pPr>
+            <a:r>
+              <a:rPr lang="en-US" sz="1800" dirty="0">
                 <a:solidFill>
                   <a:srgbClr val="FFFFFF"/>
                 </a:solidFill>
@@ -3837,16 +3921,16 @@
                 <a:ea typeface="Courier New" pitchFamily="34" charset="-122"/>
                 <a:cs typeface="Courier New" pitchFamily="34" charset="-120"/>
               </a:rPr>
-              <a:t>for f in file:</a:t>
-            </a:r>
-            <a:endParaRPr lang="en-US" sz="1600" dirty="0"/>
-          </a:p>
-          <a:p>
-            <a:pPr indent="0" marL="0">
-              <a:buNone/>
-            </a:pPr>
-            <a:r>
-              <a:rPr lang="en-US" sz="1600" dirty="0">
+              <a:t>else:</a:t>
+            </a:r>
+            <a:endParaRPr lang="en-US" sz="1800" dirty="0"/>
+          </a:p>
+          <a:p>
+            <a:pPr indent="0" marL="0">
+              <a:buNone/>
+            </a:pPr>
+            <a:r>
+              <a:rPr lang="en-US" sz="1800" dirty="0">
                 <a:solidFill>
                   <a:srgbClr val="FFFFFF"/>
                 </a:solidFill>
@@ -3854,16 +3938,16 @@
                 <a:ea typeface="Courier New" pitchFamily="34" charset="-122"/>
                 <a:cs typeface="Courier New" pitchFamily="34" charset="-120"/>
               </a:rPr>
-              <a:t>    risultati.append(riepilogo(f))</a:t>
-            </a:r>
-            <a:endParaRPr lang="en-US" sz="1600" dirty="0"/>
-          </a:p>
-          <a:p>
-            <a:pPr indent="0" marL="0">
-              <a:buNone/>
-            </a:pPr>
-            <a:r>
-              <a:rPr lang="en-US" sz="1600" dirty="0">
+              <a:t>    nota = "ok"</a:t>
+            </a:r>
+            <a:endParaRPr lang="en-US" sz="1800" dirty="0"/>
+          </a:p>
+          <a:p>
+            <a:pPr indent="0" marL="0">
+              <a:buNone/>
+            </a:pPr>
+            <a:r>
+              <a:rPr lang="en-US" sz="1800" dirty="0">
                 <a:solidFill>
                   <a:srgbClr val="FFFFFF"/>
                 </a:solidFill>
@@ -3871,22 +3955,44 @@
                 <a:ea typeface="Courier New" pitchFamily="34" charset="-122"/>
                 <a:cs typeface="Courier New" pitchFamily="34" charset="-120"/>
               </a:rPr>
-              <a:t>tab = pd.DataFrame(risultati)</a:t>
-            </a:r>
-            <a:endParaRPr lang="en-US" sz="1600" dirty="0"/>
-          </a:p>
-        </p:txBody>
-      </p:sp>
-      <p:sp>
-        <p:nvSpPr>
-          <p:cNvPr id="6" name="Text 4"/>
+              <a:t>print(nota)</a:t>
+            </a:r>
+            <a:endParaRPr lang="en-US" sz="1800" dirty="0"/>
+          </a:p>
+        </p:txBody>
+      </p:sp>
+      <p:sp>
+        <p:nvSpPr>
+          <p:cNvPr id="6" name="card-out"/>
+          <p:cNvSpPr/>
+          <p:nvPr/>
+        </p:nvSpPr>
+        <p:spPr>
+          <a:xfrm>
+            <a:off x="548640" y="4297680"/>
+            <a:ext cx="6583680" cy="914400"/>
+          </a:xfrm>
+          <a:prstGeom prst="roundRect">
+            <a:avLst>
+              <a:gd name="adj" fmla="val 12000"/>
+            </a:avLst>
+          </a:prstGeom>
+          <a:solidFill>
+            <a:srgbClr val="EEF3F4"/>
+          </a:solidFill>
+          <a:ln/>
+        </p:spPr>
+      </p:sp>
+      <p:sp>
+        <p:nvSpPr>
+          <p:cNvPr id="7" name="Text 5"/>
           <p:cNvSpPr txBox="1"/>
           <p:nvPr/>
         </p:nvSpPr>
         <p:spPr>
           <a:xfrm>
-            <a:off x="8229600" y="1828800"/>
-            <a:ext cx="3383280" cy="3840480"/>
+            <a:off x="777240" y="4434840"/>
+            <a:ext cx="1828800" cy="274320"/>
           </a:xfrm>
           <a:prstGeom prst="rect">
             <a:avLst/>
@@ -3895,115 +4001,150 @@
           <a:ln/>
         </p:spPr>
         <p:txBody>
+          <a:bodyPr wrap="square" lIns="0" tIns="0" rIns="0" bIns="0" rtlCol="0" anchor="ctr"/>
+          <a:lstStyle/>
+          <a:p>
+            <a:pPr indent="0" marL="0">
+              <a:buNone/>
+            </a:pPr>
+            <a:r>
+              <a:rPr lang="en-US" sz="1100" b="1" spc="200" kern="0" dirty="0">
+                <a:solidFill>
+                  <a:srgbClr val="5C6F7B"/>
+                </a:solidFill>
+              </a:rPr>
+              <a:t>OUTPUT</a:t>
+            </a:r>
+            <a:endParaRPr lang="en-US" sz="1100" dirty="0"/>
+          </a:p>
+        </p:txBody>
+      </p:sp>
+      <p:sp>
+        <p:nvSpPr>
+          <p:cNvPr id="8" name="Text 6"/>
+          <p:cNvSpPr txBox="1"/>
+          <p:nvPr/>
+        </p:nvSpPr>
+        <p:spPr>
+          <a:xfrm>
+            <a:off x="777240" y="4754880"/>
+            <a:ext cx="6126480" cy="320040"/>
+          </a:xfrm>
+          <a:prstGeom prst="rect">
+            <a:avLst/>
+          </a:prstGeom>
+          <a:noFill/>
+          <a:ln/>
+        </p:spPr>
+        <p:txBody>
           <a:bodyPr wrap="square" lIns="0" tIns="0" rIns="0" bIns="0" rtlCol="0" anchor="t"/>
           <a:lstStyle/>
           <a:p>
-            <a:pPr marL="342900" indent="-342900">
+            <a:pPr indent="0" marL="0">
+              <a:buNone/>
+            </a:pPr>
+            <a:r>
+              <a:rPr lang="en-US" sz="1800" dirty="0">
+                <a:solidFill>
+                  <a:srgbClr val="1F2A30"/>
+                </a:solidFill>
+                <a:latin typeface="Courier New" pitchFamily="34" charset="0"/>
+                <a:ea typeface="Courier New" pitchFamily="34" charset="-122"/>
+                <a:cs typeface="Courier New" pitchFamily="34" charset="-120"/>
+              </a:rPr>
+              <a:t>poco affidabile</a:t>
+            </a:r>
+            <a:endParaRPr lang="en-US" sz="1800" dirty="0"/>
+          </a:p>
+        </p:txBody>
+      </p:sp>
+      <p:sp>
+        <p:nvSpPr>
+          <p:cNvPr id="9" name="Text 7"/>
+          <p:cNvSpPr txBox="1"/>
+          <p:nvPr/>
+        </p:nvSpPr>
+        <p:spPr>
+          <a:xfrm>
+            <a:off x="7498080" y="1828800"/>
+            <a:ext cx="4114800" cy="3657600"/>
+          </a:xfrm>
+          <a:prstGeom prst="rect">
+            <a:avLst/>
+          </a:prstGeom>
+          <a:noFill/>
+          <a:ln/>
+        </p:spPr>
+        <p:txBody>
+          <a:bodyPr wrap="square" lIns="0" tIns="0" rIns="0" bIns="0" rtlCol="0" anchor="t"/>
+          <a:lstStyle/>
+          <a:p>
+            <a:pPr indent="0" marL="0">
               <a:spcAft>
                 <a:spcPts val="1000"/>
               </a:spcAft>
-              <a:buSzPct val="100000"/>
-              <a:buChar char="•"/>
-            </a:pPr>
-            <a:r>
-              <a:rPr lang="en-US" sz="1700" dirty="0">
+              <a:buNone/>
+            </a:pPr>
+            <a:r>
+              <a:rPr lang="en-US" sz="1900" i="1" dirty="0">
                 <a:solidFill>
                   <a:srgbClr val="1F2A30"/>
                 </a:solidFill>
               </a:rPr>
-              <a:t>glob trova tutti i file che corrispondono a uno schema</a:t>
-            </a:r>
-            <a:endParaRPr lang="en-US" sz="1700" dirty="0"/>
-          </a:p>
-          <a:p>
-            <a:pPr marL="342900" indent="-342900">
+              <a:t>«se è vero, fai questo; altrimenti, quest'altro»</a:t>
+            </a:r>
+            <a:endParaRPr lang="en-US" sz="1900" dirty="0"/>
+          </a:p>
+          <a:p>
+            <a:pPr indent="0" marL="0">
               <a:spcAft>
                 <a:spcPts val="1000"/>
               </a:spcAft>
-              <a:buSzPct val="100000"/>
-              <a:buChar char="•"/>
-            </a:pPr>
-            <a:r>
-              <a:rPr lang="en-US" sz="1700" dirty="0">
+              <a:buNone/>
+            </a:pPr>
+            <a:r>
+              <a:rPr lang="en-US" sz="1900" dirty="0">
                 <a:solidFill>
                   <a:srgbClr val="1F2A30"/>
                 </a:solidFill>
               </a:rPr>
-              <a:t>Ogni giro: un file, un riepilogo, aggiunto alla lista</a:t>
-            </a:r>
-            <a:endParaRPr lang="en-US" sz="1700" dirty="0"/>
-          </a:p>
-          <a:p>
-            <a:pPr marL="342900" indent="-342900">
+              <a:t>La condizione è un confronto (L1): True o False.</a:t>
+            </a:r>
+            <a:endParaRPr lang="en-US" sz="1900" dirty="0"/>
+          </a:p>
+          <a:p>
+            <a:pPr indent="0" marL="0">
               <a:spcAft>
                 <a:spcPts val="1000"/>
               </a:spcAft>
-              <a:buSzPct val="100000"/>
-              <a:buChar char="•"/>
-            </a:pPr>
-            <a:r>
-              <a:rPr lang="en-US" sz="1700" dirty="0">
+              <a:buNone/>
+            </a:pPr>
+            <a:r>
+              <a:rPr lang="en-US" sz="1900" dirty="0">
                 <a:solidFill>
                   <a:srgbClr val="1F2A30"/>
                 </a:solidFill>
               </a:rPr>
-              <a:t>Alla fine la lista diventa una tabella</a:t>
-            </a:r>
-            <a:endParaRPr lang="en-US" sz="1700" dirty="0"/>
-          </a:p>
-          <a:p>
-            <a:pPr marL="342900" indent="-342900">
+              <a:t>Due punti e rientro, come nei cicli.</a:t>
+            </a:r>
+            <a:endParaRPr lang="en-US" sz="1900" dirty="0"/>
+          </a:p>
+          <a:p>
+            <a:pPr indent="0" marL="0">
               <a:spcAft>
                 <a:spcPts val="1000"/>
               </a:spcAft>
-              <a:buSzPct val="100000"/>
-              <a:buChar char="•"/>
-            </a:pPr>
-            <a:r>
-              <a:rPr lang="en-US" sz="1700" b="1" dirty="0">
+              <a:buNone/>
+            </a:pPr>
+            <a:r>
+              <a:rPr lang="en-US" sz="1900" b="1" dirty="0">
                 <a:solidFill>
                   <a:srgbClr val="0F4C5C"/>
                 </a:solidFill>
               </a:rPr>
-              <a:t>20 file o 2.000: stesso codice</a:t>
-            </a:r>
-            <a:endParaRPr lang="en-US" sz="1700" dirty="0"/>
-          </a:p>
-        </p:txBody>
-      </p:sp>
-      <p:sp>
-        <p:nvSpPr>
-          <p:cNvPr id="7" name="Text 5"/>
-          <p:cNvSpPr txBox="1"/>
-          <p:nvPr/>
-        </p:nvSpPr>
-        <p:spPr>
-          <a:xfrm>
-            <a:off x="548640" y="5029200"/>
-            <a:ext cx="11064240" cy="457200"/>
-          </a:xfrm>
-          <a:prstGeom prst="rect">
-            <a:avLst/>
-          </a:prstGeom>
-          <a:noFill/>
-          <a:ln/>
-        </p:spPr>
-        <p:txBody>
-          <a:bodyPr wrap="square" lIns="0" tIns="0" rIns="0" bIns="0" rtlCol="0" anchor="ctr"/>
-          <a:lstStyle/>
-          <a:p>
-            <a:pPr indent="0" marL="0">
-              <a:buNone/>
-            </a:pPr>
-            <a:r>
-              <a:rPr lang="en-US" sz="1800" i="1" dirty="0">
-                <a:solidFill>
-                  <a:srgbClr val="0F4C5C"/>
-                </a:solidFill>
-              </a:rPr>
-              <a:t>In Colab i file del corso si scaricano con git clone: compaiono nel pannello a sinistra.</a:t>
-            </a:r>
-            <a:endParaRPr lang="en-US" sz="1800" dirty="0"/>
+              <a:t>Per le righe di una tabella si filtra (L3), non si usa if.</a:t>
+            </a:r>
+            <a:endParaRPr lang="en-US" sz="1900" dirty="0"/>
           </a:p>
         </p:txBody>
       </p:sp>
@@ -4109,7 +4250,7 @@
                   <a:srgbClr val="0F4C5C"/>
                 </a:solidFill>
               </a:rPr>
-              <a:t>Quando un ciclo si ferma</a:t>
+              <a:t>Funzione + ciclo + cartella</a:t>
             </a:r>
             <a:endParaRPr lang="en-US" sz="3600" dirty="0"/>
           </a:p>
@@ -4117,22 +4258,22 @@
       </p:sp>
       <p:sp>
         <p:nvSpPr>
-          <p:cNvPr id="3" name="Shape 1"/>
+          <p:cNvPr id="3" name="card-code"/>
           <p:cNvSpPr/>
           <p:nvPr/>
         </p:nvSpPr>
         <p:spPr>
           <a:xfrm>
             <a:off x="548640" y="1737360"/>
-            <a:ext cx="5394960" cy="2743200"/>
+            <a:ext cx="7315200" cy="2926080"/>
           </a:xfrm>
           <a:prstGeom prst="roundRect">
             <a:avLst>
-              <a:gd name="adj" fmla="val 4000"/>
+              <a:gd name="adj" fmla="val 3750"/>
             </a:avLst>
           </a:prstGeom>
           <a:solidFill>
-            <a:srgbClr val="EEF3F4"/>
+            <a:srgbClr val="1F2A30"/>
           </a:solidFill>
           <a:ln/>
         </p:spPr>
@@ -4145,8 +4286,8 @@
         </p:nvSpPr>
         <p:spPr>
           <a:xfrm>
-            <a:off x="822960" y="1965960"/>
-            <a:ext cx="4846320" cy="365760"/>
+            <a:off x="777240" y="1874520"/>
+            <a:ext cx="1828800" cy="274320"/>
           </a:xfrm>
           <a:prstGeom prst="rect">
             <a:avLst/>
@@ -4162,14 +4303,14 @@
               <a:buNone/>
             </a:pPr>
             <a:r>
-              <a:rPr lang="en-US" sz="1300" b="1" spc="200" kern="0" dirty="0">
-                <a:solidFill>
-                  <a:srgbClr val="8F5308"/>
-                </a:solidFill>
-              </a:rPr>
-              <a:t>IL TRUCCO</a:t>
-            </a:r>
-            <a:endParaRPr lang="en-US" sz="1300" dirty="0"/>
+              <a:rPr lang="en-US" sz="1100" b="1" spc="200" kern="0" dirty="0">
+                <a:solidFill>
+                  <a:srgbClr val="E09F3E"/>
+                </a:solidFill>
+              </a:rPr>
+              <a:t>PYTHON</a:t>
+            </a:r>
+            <a:endParaRPr lang="en-US" sz="1100" dirty="0"/>
           </a:p>
         </p:txBody>
       </p:sp>
@@ -4181,8 +4322,8 @@
         </p:nvSpPr>
         <p:spPr>
           <a:xfrm>
-            <a:off x="822960" y="2423160"/>
-            <a:ext cx="4846320" cy="1874520"/>
+            <a:off x="777240" y="2194560"/>
+            <a:ext cx="6858000" cy="2331720"/>
           </a:xfrm>
           <a:prstGeom prst="rect">
             <a:avLst/>
@@ -4198,38 +4339,204 @@
               <a:buNone/>
             </a:pPr>
             <a:r>
-              <a:rPr lang="en-US" sz="1900" dirty="0">
+              <a:rPr lang="en-US" sz="1600" dirty="0">
+                <a:solidFill>
+                  <a:srgbClr val="FFFFFF"/>
+                </a:solidFill>
+                <a:latin typeface="Courier New" pitchFamily="34" charset="0"/>
+                <a:ea typeface="Courier New" pitchFamily="34" charset="-122"/>
+                <a:cs typeface="Courier New" pitchFamily="34" charset="-120"/>
+              </a:rPr>
+              <a:t>from pathlib import Path</a:t>
+            </a:r>
+            <a:endParaRPr lang="en-US" sz="1600" dirty="0"/>
+          </a:p>
+          <a:p>
+            <a:pPr indent="0" marL="0">
+              <a:buNone/>
+            </a:pPr>
+            <a:endParaRPr lang="en-US" sz="1600" dirty="0"/>
+          </a:p>
+          <a:p>
+            <a:pPr indent="0" marL="0">
+              <a:buNone/>
+            </a:pPr>
+            <a:r>
+              <a:rPr lang="en-US" sz="1600" dirty="0">
+                <a:solidFill>
+                  <a:srgbClr val="FFFFFF"/>
+                </a:solidFill>
+                <a:latin typeface="Courier New" pitchFamily="34" charset="0"/>
+                <a:ea typeface="Courier New" pitchFamily="34" charset="-122"/>
+                <a:cs typeface="Courier New" pitchFamily="34" charset="-120"/>
+              </a:rPr>
+              <a:t>file = sorted(Path("dati").glob("*.xlsx"))</a:t>
+            </a:r>
+            <a:endParaRPr lang="en-US" sz="1600" dirty="0"/>
+          </a:p>
+          <a:p>
+            <a:pPr indent="0" marL="0">
+              <a:buNone/>
+            </a:pPr>
+            <a:r>
+              <a:rPr lang="en-US" sz="1600" dirty="0">
+                <a:solidFill>
+                  <a:srgbClr val="FFFFFF"/>
+                </a:solidFill>
+                <a:latin typeface="Courier New" pitchFamily="34" charset="0"/>
+                <a:ea typeface="Courier New" pitchFamily="34" charset="-122"/>
+                <a:cs typeface="Courier New" pitchFamily="34" charset="-120"/>
+              </a:rPr>
+              <a:t>risultati = []</a:t>
+            </a:r>
+            <a:endParaRPr lang="en-US" sz="1600" dirty="0"/>
+          </a:p>
+          <a:p>
+            <a:pPr indent="0" marL="0">
+              <a:buNone/>
+            </a:pPr>
+            <a:r>
+              <a:rPr lang="en-US" sz="1600" dirty="0">
+                <a:solidFill>
+                  <a:srgbClr val="FFFFFF"/>
+                </a:solidFill>
+                <a:latin typeface="Courier New" pitchFamily="34" charset="0"/>
+                <a:ea typeface="Courier New" pitchFamily="34" charset="-122"/>
+                <a:cs typeface="Courier New" pitchFamily="34" charset="-120"/>
+              </a:rPr>
+              <a:t>for f in file:</a:t>
+            </a:r>
+            <a:endParaRPr lang="en-US" sz="1600" dirty="0"/>
+          </a:p>
+          <a:p>
+            <a:pPr indent="0" marL="0">
+              <a:buNone/>
+            </a:pPr>
+            <a:r>
+              <a:rPr lang="en-US" sz="1600" dirty="0">
+                <a:solidFill>
+                  <a:srgbClr val="FFFFFF"/>
+                </a:solidFill>
+                <a:latin typeface="Courier New" pitchFamily="34" charset="0"/>
+                <a:ea typeface="Courier New" pitchFamily="34" charset="-122"/>
+                <a:cs typeface="Courier New" pitchFamily="34" charset="-120"/>
+              </a:rPr>
+              <a:t>    risultati.append(riepilogo(f))</a:t>
+            </a:r>
+            <a:endParaRPr lang="en-US" sz="1600" dirty="0"/>
+          </a:p>
+          <a:p>
+            <a:pPr indent="0" marL="0">
+              <a:buNone/>
+            </a:pPr>
+            <a:r>
+              <a:rPr lang="en-US" sz="1600" dirty="0">
+                <a:solidFill>
+                  <a:srgbClr val="FFFFFF"/>
+                </a:solidFill>
+                <a:latin typeface="Courier New" pitchFamily="34" charset="0"/>
+                <a:ea typeface="Courier New" pitchFamily="34" charset="-122"/>
+                <a:cs typeface="Courier New" pitchFamily="34" charset="-120"/>
+              </a:rPr>
+              <a:t>tab = pd.DataFrame(risultati)</a:t>
+            </a:r>
+            <a:endParaRPr lang="en-US" sz="1600" dirty="0"/>
+          </a:p>
+        </p:txBody>
+      </p:sp>
+      <p:sp>
+        <p:nvSpPr>
+          <p:cNvPr id="6" name="Text 4"/>
+          <p:cNvSpPr txBox="1"/>
+          <p:nvPr/>
+        </p:nvSpPr>
+        <p:spPr>
+          <a:xfrm>
+            <a:off x="8229600" y="1828800"/>
+            <a:ext cx="3383280" cy="3840480"/>
+          </a:xfrm>
+          <a:prstGeom prst="rect">
+            <a:avLst/>
+          </a:prstGeom>
+          <a:noFill/>
+          <a:ln/>
+        </p:spPr>
+        <p:txBody>
+          <a:bodyPr wrap="square" lIns="0" tIns="0" rIns="0" bIns="0" rtlCol="0" anchor="t"/>
+          <a:lstStyle/>
+          <a:p>
+            <a:pPr marL="342900" indent="-342900">
+              <a:spcAft>
+                <a:spcPts val="1000"/>
+              </a:spcAft>
+              <a:buSzPct val="100000"/>
+              <a:buChar char="•"/>
+            </a:pPr>
+            <a:r>
+              <a:rPr lang="en-US" sz="1700" dirty="0">
                 <a:solidFill>
                   <a:srgbClr val="1F2A30"/>
                 </a:solidFill>
               </a:rPr>
-              <a:t>Stampa il nome del file prima di elaborarlo. Se si ferma con un errore, l'ultimo nome stampato è il colpevole.</a:t>
-            </a:r>
-            <a:endParaRPr lang="en-US" sz="1900" dirty="0"/>
-          </a:p>
-        </p:txBody>
-      </p:sp>
-      <p:sp>
-        <p:nvSpPr>
-          <p:cNvPr id="6" name="Shape 4"/>
-          <p:cNvSpPr/>
-          <p:nvPr/>
-        </p:nvSpPr>
-        <p:spPr>
-          <a:xfrm>
-            <a:off x="6217920" y="1737360"/>
-            <a:ext cx="5394960" cy="2743200"/>
-          </a:xfrm>
-          <a:prstGeom prst="roundRect">
-            <a:avLst>
-              <a:gd name="adj" fmla="val 4000"/>
-            </a:avLst>
-          </a:prstGeom>
-          <a:solidFill>
-            <a:srgbClr val="0F4C5C"/>
-          </a:solidFill>
-          <a:ln/>
-        </p:spPr>
+              <a:t>glob trova tutti i file che corrispondono a uno schema</a:t>
+            </a:r>
+            <a:endParaRPr lang="en-US" sz="1700" dirty="0"/>
+          </a:p>
+          <a:p>
+            <a:pPr marL="342900" indent="-342900">
+              <a:spcAft>
+                <a:spcPts val="1000"/>
+              </a:spcAft>
+              <a:buSzPct val="100000"/>
+              <a:buChar char="•"/>
+            </a:pPr>
+            <a:r>
+              <a:rPr lang="en-US" sz="1700" dirty="0">
+                <a:solidFill>
+                  <a:srgbClr val="1F2A30"/>
+                </a:solidFill>
+              </a:rPr>
+              <a:t>Ogni giro: un file, un riepilogo, aggiunto alla lista</a:t>
+            </a:r>
+            <a:endParaRPr lang="en-US" sz="1700" dirty="0"/>
+          </a:p>
+          <a:p>
+            <a:pPr marL="342900" indent="-342900">
+              <a:spcAft>
+                <a:spcPts val="1000"/>
+              </a:spcAft>
+              <a:buSzPct val="100000"/>
+              <a:buChar char="•"/>
+            </a:pPr>
+            <a:r>
+              <a:rPr lang="en-US" sz="1700" dirty="0">
+                <a:solidFill>
+                  <a:srgbClr val="1F2A30"/>
+                </a:solidFill>
+              </a:rPr>
+              <a:t>Alla fine la lista diventa una tabella</a:t>
+            </a:r>
+            <a:endParaRPr lang="en-US" sz="1700" dirty="0"/>
+          </a:p>
+          <a:p>
+            <a:pPr marL="342900" indent="-342900">
+              <a:spcAft>
+                <a:spcPts val="1000"/>
+              </a:spcAft>
+              <a:buSzPct val="100000"/>
+              <a:buChar char="•"/>
+            </a:pPr>
+            <a:r>
+              <a:rPr lang="en-US" sz="1700" b="1" dirty="0">
+                <a:solidFill>
+                  <a:srgbClr val="0F4C5C"/>
+                </a:solidFill>
+              </a:rPr>
+              <a:t>20 file o 2.000: stesso codice</a:t>
+            </a:r>
+            <a:endParaRPr lang="en-US" sz="1700" dirty="0"/>
+          </a:p>
+        </p:txBody>
       </p:sp>
       <p:sp>
         <p:nvSpPr>
@@ -4239,8 +4546,8 @@
         </p:nvSpPr>
         <p:spPr>
           <a:xfrm>
-            <a:off x="6492240" y="1965960"/>
-            <a:ext cx="4846320" cy="365760"/>
+            <a:off x="548640" y="5029200"/>
+            <a:ext cx="11064240" cy="457200"/>
           </a:xfrm>
           <a:prstGeom prst="rect">
             <a:avLst/>
@@ -4256,84 +4563,12 @@
               <a:buNone/>
             </a:pPr>
             <a:r>
-              <a:rPr lang="en-US" sz="1300" b="1" spc="200" kern="0" dirty="0">
-                <a:solidFill>
-                  <a:srgbClr val="F4C06E"/>
-                </a:solidFill>
-              </a:rPr>
-              <a:t>POI</a:t>
-            </a:r>
-            <a:endParaRPr lang="en-US" sz="1300" dirty="0"/>
-          </a:p>
-        </p:txBody>
-      </p:sp>
-      <p:sp>
-        <p:nvSpPr>
-          <p:cNvPr id="8" name="Text 6"/>
-          <p:cNvSpPr txBox="1"/>
-          <p:nvPr/>
-        </p:nvSpPr>
-        <p:spPr>
-          <a:xfrm>
-            <a:off x="6492240" y="2423160"/>
-            <a:ext cx="4846320" cy="1874520"/>
-          </a:xfrm>
-          <a:prstGeom prst="rect">
-            <a:avLst/>
-          </a:prstGeom>
-          <a:noFill/>
-          <a:ln/>
-        </p:spPr>
-        <p:txBody>
-          <a:bodyPr wrap="square" lIns="0" tIns="0" rIns="0" bIns="0" rtlCol="0" anchor="t"/>
-          <a:lstStyle/>
-          <a:p>
-            <a:pPr indent="0" marL="0">
-              <a:buNone/>
-            </a:pPr>
-            <a:r>
-              <a:rPr lang="en-US" sz="1900" dirty="0">
-                <a:solidFill>
-                  <a:srgbClr val="FFFFFF"/>
-                </a:solidFill>
-              </a:rPr>
-              <a:t>Apri quel file e guardalo: cosa ha di diverso dagli altri? Correggi la funzione in modo che regga anche quel caso.</a:t>
-            </a:r>
-            <a:endParaRPr lang="en-US" sz="1900" dirty="0"/>
-          </a:p>
-        </p:txBody>
-      </p:sp>
-      <p:sp>
-        <p:nvSpPr>
-          <p:cNvPr id="9" name="Text 7"/>
-          <p:cNvSpPr txBox="1"/>
-          <p:nvPr/>
-        </p:nvSpPr>
-        <p:spPr>
-          <a:xfrm>
-            <a:off x="548640" y="4846320"/>
-            <a:ext cx="11064240" cy="457200"/>
-          </a:xfrm>
-          <a:prstGeom prst="rect">
-            <a:avLst/>
-          </a:prstGeom>
-          <a:noFill/>
-          <a:ln/>
-        </p:spPr>
-        <p:txBody>
-          <a:bodyPr wrap="square" lIns="0" tIns="0" rIns="0" bIns="0" rtlCol="0" anchor="ctr"/>
-          <a:lstStyle/>
-          <a:p>
-            <a:pPr indent="0" marL="0">
-              <a:buNone/>
-            </a:pPr>
-            <a:r>
               <a:rPr lang="en-US" sz="1800" i="1" dirty="0">
                 <a:solidFill>
                   <a:srgbClr val="0F4C5C"/>
                 </a:solidFill>
               </a:rPr>
-              <a:t>I file «tutti uguali» non sono mai tutti uguali.</a:t>
+              <a:t>In Colab i file del corso si scaricano con git clone: compaiono nel pannello a sinistra.</a:t>
             </a:r>
             <a:endParaRPr lang="en-US" sz="1800" dirty="0"/>
           </a:p>
@@ -4419,8 +4654,8 @@
         </p:nvSpPr>
         <p:spPr>
           <a:xfrm>
-            <a:off x="731520" y="2194560"/>
-            <a:ext cx="10698480" cy="1280160"/>
+            <a:off x="548640" y="365760"/>
+            <a:ext cx="11064240" cy="822960"/>
           </a:xfrm>
           <a:prstGeom prst="rect">
             <a:avLst/>
@@ -4429,36 +4664,222 @@
           <a:ln/>
         </p:spPr>
         <p:txBody>
-          <a:bodyPr wrap="square" lIns="0" tIns="0" rIns="0" bIns="0" rtlCol="0" anchor="b"/>
+          <a:bodyPr wrap="square" lIns="0" tIns="0" rIns="0" bIns="0" rtlCol="0" anchor="ctr"/>
           <a:lstStyle/>
           <a:p>
             <a:pPr algn="l" indent="0" marL="0">
               <a:buNone/>
             </a:pPr>
             <a:r>
-              <a:rPr lang="en-US" sz="5400" b="1" dirty="0">
+              <a:rPr lang="en-US" sz="3600" b="1" dirty="0">
+                <a:solidFill>
+                  <a:srgbClr val="0F4C5C"/>
+                </a:solidFill>
+              </a:rPr>
+              <a:t>Quando un ciclo si ferma</a:t>
+            </a:r>
+            <a:endParaRPr lang="en-US" sz="3600" dirty="0"/>
+          </a:p>
+        </p:txBody>
+      </p:sp>
+      <p:sp>
+        <p:nvSpPr>
+          <p:cNvPr id="3" name="Shape 1"/>
+          <p:cNvSpPr/>
+          <p:nvPr/>
+        </p:nvSpPr>
+        <p:spPr>
+          <a:xfrm>
+            <a:off x="548640" y="1737360"/>
+            <a:ext cx="5394960" cy="2743200"/>
+          </a:xfrm>
+          <a:prstGeom prst="roundRect">
+            <a:avLst>
+              <a:gd name="adj" fmla="val 4000"/>
+            </a:avLst>
+          </a:prstGeom>
+          <a:solidFill>
+            <a:srgbClr val="EEF3F4"/>
+          </a:solidFill>
+          <a:ln/>
+        </p:spPr>
+      </p:sp>
+      <p:sp>
+        <p:nvSpPr>
+          <p:cNvPr id="4" name="Text 2"/>
+          <p:cNvSpPr txBox="1"/>
+          <p:nvPr/>
+        </p:nvSpPr>
+        <p:spPr>
+          <a:xfrm>
+            <a:off x="822960" y="1965960"/>
+            <a:ext cx="4846320" cy="365760"/>
+          </a:xfrm>
+          <a:prstGeom prst="rect">
+            <a:avLst/>
+          </a:prstGeom>
+          <a:noFill/>
+          <a:ln/>
+        </p:spPr>
+        <p:txBody>
+          <a:bodyPr wrap="square" lIns="0" tIns="0" rIns="0" bIns="0" rtlCol="0" anchor="ctr"/>
+          <a:lstStyle/>
+          <a:p>
+            <a:pPr indent="0" marL="0">
+              <a:buNone/>
+            </a:pPr>
+            <a:r>
+              <a:rPr lang="en-US" sz="1300" b="1" spc="200" kern="0" dirty="0">
+                <a:solidFill>
+                  <a:srgbClr val="8F5308"/>
+                </a:solidFill>
+              </a:rPr>
+              <a:t>IL TRUCCO</a:t>
+            </a:r>
+            <a:endParaRPr lang="en-US" sz="1300" dirty="0"/>
+          </a:p>
+        </p:txBody>
+      </p:sp>
+      <p:sp>
+        <p:nvSpPr>
+          <p:cNvPr id="5" name="Text 3"/>
+          <p:cNvSpPr txBox="1"/>
+          <p:nvPr/>
+        </p:nvSpPr>
+        <p:spPr>
+          <a:xfrm>
+            <a:off x="822960" y="2423160"/>
+            <a:ext cx="4846320" cy="1874520"/>
+          </a:xfrm>
+          <a:prstGeom prst="rect">
+            <a:avLst/>
+          </a:prstGeom>
+          <a:noFill/>
+          <a:ln/>
+        </p:spPr>
+        <p:txBody>
+          <a:bodyPr wrap="square" lIns="0" tIns="0" rIns="0" bIns="0" rtlCol="0" anchor="t"/>
+          <a:lstStyle/>
+          <a:p>
+            <a:pPr indent="0" marL="0">
+              <a:buNone/>
+            </a:pPr>
+            <a:r>
+              <a:rPr lang="en-US" sz="1900" dirty="0">
+                <a:solidFill>
+                  <a:srgbClr val="1F2A30"/>
+                </a:solidFill>
+              </a:rPr>
+              <a:t>Stampa il nome del file prima di elaborarlo. Se si ferma con un errore, l'ultimo nome stampato è il colpevole.</a:t>
+            </a:r>
+            <a:endParaRPr lang="en-US" sz="1900" dirty="0"/>
+          </a:p>
+        </p:txBody>
+      </p:sp>
+      <p:sp>
+        <p:nvSpPr>
+          <p:cNvPr id="6" name="Shape 4"/>
+          <p:cNvSpPr/>
+          <p:nvPr/>
+        </p:nvSpPr>
+        <p:spPr>
+          <a:xfrm>
+            <a:off x="6217920" y="1737360"/>
+            <a:ext cx="5394960" cy="2743200"/>
+          </a:xfrm>
+          <a:prstGeom prst="roundRect">
+            <a:avLst>
+              <a:gd name="adj" fmla="val 4000"/>
+            </a:avLst>
+          </a:prstGeom>
+          <a:solidFill>
+            <a:srgbClr val="0F4C5C"/>
+          </a:solidFill>
+          <a:ln/>
+        </p:spPr>
+      </p:sp>
+      <p:sp>
+        <p:nvSpPr>
+          <p:cNvPr id="7" name="Text 5"/>
+          <p:cNvSpPr txBox="1"/>
+          <p:nvPr/>
+        </p:nvSpPr>
+        <p:spPr>
+          <a:xfrm>
+            <a:off x="6492240" y="1965960"/>
+            <a:ext cx="4846320" cy="365760"/>
+          </a:xfrm>
+          <a:prstGeom prst="rect">
+            <a:avLst/>
+          </a:prstGeom>
+          <a:noFill/>
+          <a:ln/>
+        </p:spPr>
+        <p:txBody>
+          <a:bodyPr wrap="square" lIns="0" tIns="0" rIns="0" bIns="0" rtlCol="0" anchor="ctr"/>
+          <a:lstStyle/>
+          <a:p>
+            <a:pPr indent="0" marL="0">
+              <a:buNone/>
+            </a:pPr>
+            <a:r>
+              <a:rPr lang="en-US" sz="1300" b="1" spc="200" kern="0" dirty="0">
+                <a:solidFill>
+                  <a:srgbClr val="F4C06E"/>
+                </a:solidFill>
+              </a:rPr>
+              <a:t>POI</a:t>
+            </a:r>
+            <a:endParaRPr lang="en-US" sz="1300" dirty="0"/>
+          </a:p>
+        </p:txBody>
+      </p:sp>
+      <p:sp>
+        <p:nvSpPr>
+          <p:cNvPr id="8" name="Text 6"/>
+          <p:cNvSpPr txBox="1"/>
+          <p:nvPr/>
+        </p:nvSpPr>
+        <p:spPr>
+          <a:xfrm>
+            <a:off x="6492240" y="2423160"/>
+            <a:ext cx="4846320" cy="1874520"/>
+          </a:xfrm>
+          <a:prstGeom prst="rect">
+            <a:avLst/>
+          </a:prstGeom>
+          <a:noFill/>
+          <a:ln/>
+        </p:spPr>
+        <p:txBody>
+          <a:bodyPr wrap="square" lIns="0" tIns="0" rIns="0" bIns="0" rtlCol="0" anchor="t"/>
+          <a:lstStyle/>
+          <a:p>
+            <a:pPr indent="0" marL="0">
+              <a:buNone/>
+            </a:pPr>
+            <a:r>
+              <a:rPr lang="en-US" sz="1900" dirty="0">
                 <a:solidFill>
                   <a:srgbClr val="FFFFFF"/>
                 </a:solidFill>
               </a:rPr>
-              <a:t>Task: 20 file, un riepilogo</a:t>
-            </a:r>
-            <a:endParaRPr lang="en-US" sz="5400" dirty="0"/>
-          </a:p>
-        </p:txBody>
-      </p:sp>
-      <p:sp>
-        <p:nvSpPr>
-          <p:cNvPr id="3" name="Text 0"/>
-          <p:cNvSpPr/>
-          <p:nvPr>
-            <p:ph idx="101" type="body" hasCustomPrompt="1"/>
-          </p:nvPr>
-        </p:nvSpPr>
-        <p:spPr>
-          <a:xfrm>
-            <a:off x="731520" y="3657600"/>
-            <a:ext cx="10698480" cy="1463040"/>
+              <a:t>Apri quel file e guardalo: cosa ha di diverso dagli altri? Correggi la funzione in modo che regga anche quel caso.</a:t>
+            </a:r>
+            <a:endParaRPr lang="en-US" sz="1900" dirty="0"/>
+          </a:p>
+        </p:txBody>
+      </p:sp>
+      <p:sp>
+        <p:nvSpPr>
+          <p:cNvPr id="9" name="Text 7"/>
+          <p:cNvSpPr txBox="1"/>
+          <p:nvPr/>
+        </p:nvSpPr>
+        <p:spPr>
+          <a:xfrm>
+            <a:off x="548640" y="4846320"/>
+            <a:ext cx="11064240" cy="457200"/>
           </a:xfrm>
           <a:prstGeom prst="rect">
             <a:avLst/>
@@ -4467,35 +4888,66 @@
           <a:ln/>
         </p:spPr>
         <p:txBody>
-          <a:bodyPr wrap="square" lIns="0" tIns="0" rIns="0" bIns="0" rtlCol="0" anchor="t"/>
-          <a:lstStyle/>
-          <a:p>
-            <a:pPr indent="0" marL="0">
-              <a:buNone/>
-            </a:pPr>
-            <a:r>
-              <a:rPr lang="en-US" sz="2200" dirty="0">
-                <a:solidFill>
-                  <a:srgbClr val="B8C4CB"/>
-                </a:solidFill>
-              </a:rPr>
-              <a:t>Scrivi la ricetta una volta, ripetila su tutti.</a:t>
-            </a:r>
-            <a:endParaRPr lang="en-US" sz="2200" dirty="0"/>
-          </a:p>
-          <a:p>
-            <a:pPr indent="0" marL="0">
-              <a:buNone/>
-            </a:pPr>
-            <a:r>
-              <a:rPr lang="en-US" sz="2200" dirty="0">
-                <a:solidFill>
-                  <a:srgbClr val="B8C4CB"/>
-                </a:solidFill>
-              </a:rPr>
-              <a:t>60 minuti · apri il notebook dal README</a:t>
-            </a:r>
-            <a:endParaRPr lang="en-US" sz="2200" dirty="0"/>
+          <a:bodyPr wrap="square" lIns="0" tIns="0" rIns="0" bIns="0" rtlCol="0" anchor="ctr"/>
+          <a:lstStyle/>
+          <a:p>
+            <a:pPr indent="0" marL="0">
+              <a:buNone/>
+            </a:pPr>
+            <a:r>
+              <a:rPr lang="en-US" sz="1800" i="1" dirty="0">
+                <a:solidFill>
+                  <a:srgbClr val="0F4C5C"/>
+                </a:solidFill>
+              </a:rPr>
+              <a:t>I file «tutti uguali» non sono mai tutti uguali.</a:t>
+            </a:r>
+            <a:endParaRPr lang="en-US" sz="1800" dirty="0"/>
+          </a:p>
+        </p:txBody>
+      </p:sp>
+      <p:sp>
+        <p:nvSpPr>
+          <p:cNvPr id="25" name="Slide Number Placeholder 0"/>
+          <p:cNvSpPr>
+            <a:spLocks noGrp="1"/>
+          </p:cNvSpPr>
+          <p:nvPr>
+            <p:ph type="sldNum" sz="quarter" idx="4294967295"/>
+          </p:nvPr>
+        </p:nvSpPr>
+        <p:spPr>
+          <a:xfrm>
+            <a:off x="11155680" y="6400800"/>
+            <a:ext cx="457200" cy="274320"/>
+          </a:xfrm>
+          <a:prstGeom prst="rect">
+            <a:avLst/>
+          </a:prstGeom>
+          <a:extLst>
+            <a:ext uri="{C572A759-6A51-4108-AA02-DFA0A04FC94B}">
+              <ma14:wrappingTextBoxFlag xmlns:ma14="http://schemas.microsoft.com/office/mac/drawingml/2011/main" val="0"/>
+            </a:ext>
+          </a:extLst>
+        </p:spPr>
+        <p:txBody>
+          <a:bodyPr/>
+          <a:lstStyle>
+            <a:lvl1pPr>
+              <a:defRPr sz="1000">
+                <a:solidFill>
+                  <a:srgbClr val="5C6F7B"/>
+                </a:solidFill>
+              </a:defRPr>
+            </a:lvl1pPr>
+          </a:lstStyle>
+          <a:p>
+            <a:pPr algn="r"/>
+            <a:fld id="{F7021451-1387-4CA6-816F-3879F97B5CBC}" type="slidenum">
+              <a:rPr b="0" lang="en-US"/>
+              <a:t>7</a:t>
+            </a:fld>
+            <a:endParaRPr lang="en-US"/>
           </a:p>
         </p:txBody>
       </p:sp>
@@ -4510,6 +4962,121 @@
 <file path=ppt/slides/slide8.xml><?xml version="1.0" encoding="utf-8"?>
 <p:sld xmlns:a="http://schemas.openxmlformats.org/drawingml/2006/main" xmlns:r="http://schemas.openxmlformats.org/officeDocument/2006/relationships" xmlns:p="http://schemas.openxmlformats.org/presentationml/2006/main">
   <p:cSld name="Slide 8">
+    <p:spTree>
+      <p:nvGrpSpPr>
+        <p:cNvPr id="1" name=""/>
+        <p:cNvGrpSpPr/>
+        <p:nvPr/>
+      </p:nvGrpSpPr>
+      <p:grpSpPr>
+        <a:xfrm>
+          <a:off x="0" y="0"/>
+          <a:ext cx="0" cy="0"/>
+          <a:chOff x="0" y="0"/>
+          <a:chExt cx="0" cy="0"/>
+        </a:xfrm>
+      </p:grpSpPr>
+      <p:sp>
+        <p:nvSpPr>
+          <p:cNvPr id="2" name="Text 0"/>
+          <p:cNvSpPr/>
+          <p:nvPr>
+            <p:ph idx="100" type="title" hasCustomPrompt="1"/>
+          </p:nvPr>
+        </p:nvSpPr>
+        <p:spPr>
+          <a:xfrm>
+            <a:off x="731520" y="2194560"/>
+            <a:ext cx="10698480" cy="1280160"/>
+          </a:xfrm>
+          <a:prstGeom prst="rect">
+            <a:avLst/>
+          </a:prstGeom>
+          <a:noFill/>
+          <a:ln/>
+        </p:spPr>
+        <p:txBody>
+          <a:bodyPr wrap="square" lIns="0" tIns="0" rIns="0" bIns="0" rtlCol="0" anchor="b"/>
+          <a:lstStyle/>
+          <a:p>
+            <a:pPr algn="l" indent="0" marL="0">
+              <a:buNone/>
+            </a:pPr>
+            <a:r>
+              <a:rPr lang="en-US" sz="5400" b="1" dirty="0">
+                <a:solidFill>
+                  <a:srgbClr val="FFFFFF"/>
+                </a:solidFill>
+              </a:rPr>
+              <a:t>Task: 20 file, un riepilogo</a:t>
+            </a:r>
+            <a:endParaRPr lang="en-US" sz="5400" dirty="0"/>
+          </a:p>
+        </p:txBody>
+      </p:sp>
+      <p:sp>
+        <p:nvSpPr>
+          <p:cNvPr id="3" name="Text 0"/>
+          <p:cNvSpPr/>
+          <p:nvPr>
+            <p:ph idx="101" type="body" hasCustomPrompt="1"/>
+          </p:nvPr>
+        </p:nvSpPr>
+        <p:spPr>
+          <a:xfrm>
+            <a:off x="731520" y="3657600"/>
+            <a:ext cx="10698480" cy="1463040"/>
+          </a:xfrm>
+          <a:prstGeom prst="rect">
+            <a:avLst/>
+          </a:prstGeom>
+          <a:noFill/>
+          <a:ln/>
+        </p:spPr>
+        <p:txBody>
+          <a:bodyPr wrap="square" lIns="0" tIns="0" rIns="0" bIns="0" rtlCol="0" anchor="t"/>
+          <a:lstStyle/>
+          <a:p>
+            <a:pPr indent="0" marL="0">
+              <a:buNone/>
+            </a:pPr>
+            <a:r>
+              <a:rPr lang="en-US" sz="2200" dirty="0">
+                <a:solidFill>
+                  <a:srgbClr val="B8C4CB"/>
+                </a:solidFill>
+              </a:rPr>
+              <a:t>Scrivi la ricetta una volta, ripetila su tutti.</a:t>
+            </a:r>
+            <a:endParaRPr lang="en-US" sz="2200" dirty="0"/>
+          </a:p>
+          <a:p>
+            <a:pPr indent="0" marL="0">
+              <a:buNone/>
+            </a:pPr>
+            <a:r>
+              <a:rPr lang="en-US" sz="2200" dirty="0">
+                <a:solidFill>
+                  <a:srgbClr val="B8C4CB"/>
+                </a:solidFill>
+              </a:rPr>
+              <a:t>60 minuti · apri il notebook dal README</a:t>
+            </a:r>
+            <a:endParaRPr lang="en-US" sz="2200" dirty="0"/>
+          </a:p>
+        </p:txBody>
+      </p:sp>
+    </p:spTree>
+  </p:cSld>
+  <p:clrMapOvr>
+    <a:masterClrMapping/>
+  </p:clrMapOvr>
+</p:sld>
+</file>
+
+<file path=ppt/slides/slide9.xml><?xml version="1.0" encoding="utf-8"?>
+<p:sld xmlns:a="http://schemas.openxmlformats.org/drawingml/2006/main" xmlns:r="http://schemas.openxmlformats.org/officeDocument/2006/relationships" xmlns:p="http://schemas.openxmlformats.org/presentationml/2006/main">
+  <p:cSld name="Slide 9">
     <p:spTree>
       <p:nvGrpSpPr>
         <p:cNvPr id="1" name=""/>

</xml_diff>